<commit_message>
Add detailed Machine Learning introduction slides
Replaced the placeholder content in Slide 3 with detailed slides covering Introduction to ML, Applications, Types, and Challenges. Used a consistent layout with titles and bullet points, and included descriptive placeholders for image generation.

Co-authored-by: saurabh1604 <62421483+saurabh1604@users.noreply.github.com>
</commit_message>
<xml_diff>
--- a/WILP_PPT_Securityencrypted_3_ratio 4.3_28th Jan.pptx
+++ b/WILP_PPT_Securityencrypted_3_ratio 4.3_28th Jan.pptx
@@ -10,8 +10,11 @@
   <p:sldIdLst>
     <p:sldId id="256" r:id="rId2"/>
     <p:sldId id="257" r:id="rId3"/>
-    <p:sldId id="258" r:id="rId4"/>
-    <p:sldId id="259" r:id="rId5"/>
+    <p:sldId id="258" r:id="rId11"/>
+    <p:sldId id="259" r:id="rId12"/>
+    <p:sldId id="260" r:id="rId13"/>
+    <p:sldId id="261" r:id="rId14"/>
+    <p:sldId id="262" r:id="rId15"/>
   </p:sldIdLst>
   <p:sldSz cx="9144000" cy="6858000" type="screen4x3"/>
   <p:notesSz cx="6858000" cy="9144000"/>
@@ -8536,7 +8539,7 @@
 </file>
 
 <file path=ppt/slides/slide3.xml><?xml version="1.0" encoding="utf-8"?>
-<p:sld xmlns:a="http://schemas.openxmlformats.org/drawingml/2006/main" xmlns:r="http://schemas.openxmlformats.org/officeDocument/2006/relationships" xmlns:p="http://schemas.openxmlformats.org/presentationml/2006/main">
+<p:sld xmlns:a="http://schemas.openxmlformats.org/drawingml/2006/main" xmlns:p="http://schemas.openxmlformats.org/presentationml/2006/main" xmlns:r="http://schemas.openxmlformats.org/officeDocument/2006/relationships">
   <p:cSld>
     <p:spTree>
       <p:nvGrpSpPr>
@@ -8544,101 +8547,112 @@
         <p:cNvGrpSpPr/>
         <p:nvPr/>
       </p:nvGrpSpPr>
-      <p:grpSpPr>
-        <a:xfrm>
-          <a:off x="0" y="0"/>
-          <a:ext cx="0" cy="0"/>
-          <a:chOff x="0" y="0"/>
-          <a:chExt cx="0" cy="0"/>
-        </a:xfrm>
-      </p:grpSpPr>
+      <p:grpSpPr/>
       <p:sp>
         <p:nvSpPr>
-          <p:cNvPr id="355" name="Content Placeholder 2"/>
-          <p:cNvSpPr txBox="1">
+          <p:cNvPr id="2" name="Text Placeholder 1"/>
+          <p:cNvSpPr>
             <a:spLocks noGrp="1"/>
           </p:cNvSpPr>
           <p:nvPr>
-            <p:ph type="body" idx="1"/>
+            <p:ph type="body" idx="1" sz="quarter"/>
           </p:nvPr>
         </p:nvSpPr>
-        <p:spPr>
-          <a:xfrm>
-            <a:off x="304800" y="1493837"/>
-            <a:ext cx="8229600" cy="4525964"/>
-          </a:xfrm>
-          <a:prstGeom prst="rect">
-            <a:avLst/>
-          </a:prstGeom>
-        </p:spPr>
+        <p:spPr/>
         <p:txBody>
-          <a:bodyPr anchor="t"/>
-          <a:lstStyle>
-            <a:lvl1pPr indent="-342900">
-              <a:lnSpc>
-                <a:spcPct val="100000"/>
-              </a:lnSpc>
-              <a:spcBef>
-                <a:spcPts val="500"/>
-              </a:spcBef>
-              <a:defRPr sz="2400" b="0" spc="0">
-                <a:latin typeface="Open Sans"/>
-                <a:ea typeface="Open Sans"/>
-                <a:cs typeface="Open Sans"/>
-                <a:sym typeface="Open Sans"/>
-              </a:defRPr>
-            </a:lvl1pPr>
-          </a:lstStyle>
-          <a:p>
+          <a:bodyPr/>
+          <a:lstStyle/>
+          <a:p>
+            <a:pPr/>
             <a:r>
-              <a:t>Lorem ipsum dolor sit amet, consectetur adipiscing elit, sed do eiusmod tempor incididunt ut labore et dolore magna aliqua. Ut enim ad minim veniam, quis nostrud exercitation ullamco laboris nisi ut aliquip ex ea commodo consequat. Duis aute irure dolor in reprehenderit in voluptate velit esse cillum dolore eu fugiat nulla pariatur. Excepteur sint occaecat cupidatat non proident, sunt in culpa qui officia deserunt mollit anim id est laborum</a:t>
+              <a:t>What is Machine Learning?</a:t>
+            </a:r>
+          </a:p>
+          <a:p>
+            <a:pPr lvl="1"/>
+            <a:r>
+              <a:t>A subset of AI that enables systems to learn from data without explicit programming.</a:t>
+            </a:r>
+          </a:p>
+          <a:p>
+            <a:pPr/>
+            <a:r>
+              <a:t>Why Now?</a:t>
+            </a:r>
+          </a:p>
+          <a:p>
+            <a:pPr lvl="1"/>
+            <a:r>
+              <a:t>Explosion of Big Data availability.</a:t>
+            </a:r>
+          </a:p>
+          <a:p>
+            <a:pPr lvl="1"/>
+            <a:r>
+              <a:t>Advancements in computational power (GPUs/TPUs).</a:t>
+            </a:r>
+          </a:p>
+          <a:p>
+            <a:pPr lvl="1"/>
+            <a:r>
+              <a:t>Improvements in algorithms (Deep Learning).</a:t>
             </a:r>
           </a:p>
         </p:txBody>
       </p:sp>
       <p:sp>
         <p:nvSpPr>
-          <p:cNvPr id="356" name="Content Placeholder 4"/>
+          <p:cNvPr id="3" name="Title 2"/>
+          <p:cNvSpPr>
+            <a:spLocks noGrp="1"/>
+          </p:cNvSpPr>
+          <p:nvPr>
+            <p:ph type="title"/>
+          </p:nvPr>
+        </p:nvSpPr>
+        <p:spPr/>
+        <p:txBody>
+          <a:bodyPr/>
+          <a:lstStyle/>
+          <a:p>
+            <a:r>
+              <a:t>Introduction to Machine Learning: What and Why</a:t>
+            </a:r>
+          </a:p>
+        </p:txBody>
+      </p:sp>
+      <p:sp>
+        <p:nvSpPr>
+          <p:cNvPr id="4" name="TextBox 3"/>
           <p:cNvSpPr txBox="1"/>
           <p:nvPr/>
         </p:nvSpPr>
         <p:spPr>
           <a:xfrm>
-            <a:off x="350519" y="152400"/>
-            <a:ext cx="6233162" cy="1143000"/>
+            <a:off x="914400" y="5029200"/>
+            <a:ext cx="7315200" cy="1371600"/>
           </a:xfrm>
           <a:prstGeom prst="rect">
             <a:avLst/>
           </a:prstGeom>
-          <a:ln w="12700">
-            <a:miter lim="400000"/>
-          </a:ln>
-          <a:extLst>
-            <a:ext uri="{C572A759-6A51-4108-AA02-DFA0A04FC94B}">
-              <ma14:wrappingTextBoxFlag xmlns="" xmlns:m="http://schemas.openxmlformats.org/officeDocument/2006/math" xmlns:a14="http://schemas.microsoft.com/office/drawing/2010/main" xmlns:ma14="http://schemas.microsoft.com/office/mac/drawingml/2011/main" val="1"/>
-            </a:ext>
-          </a:extLst>
+          <a:noFill/>
         </p:spPr>
         <p:txBody>
-          <a:bodyPr lIns="45719" rIns="45719" anchor="ctr">
-            <a:normAutofit/>
+          <a:bodyPr wrap="square">
+            <a:spAutoFit/>
           </a:bodyPr>
-          <a:lstStyle>
-            <a:lvl1pPr marL="342900" indent="-685800">
-              <a:lnSpc>
-                <a:spcPts val="3600"/>
-              </a:lnSpc>
-              <a:defRPr sz="3600" b="1" spc="-200">
-                <a:latin typeface="+mj-lt"/>
-                <a:ea typeface="+mj-ea"/>
-                <a:cs typeface="+mj-cs"/>
-                <a:sym typeface="Arial"/>
+          <a:lstStyle/>
+          <a:p/>
+          <a:p>
+            <a:pPr>
+              <a:defRPr sz="1200" i="1">
+                <a:solidFill>
+                  <a:srgbClr val="646464"/>
+                </a:solidFill>
               </a:defRPr>
-            </a:lvl1pPr>
-          </a:lstStyle>
-          <a:p>
+            </a:pPr>
             <a:r>
-              <a:t>TEST</a:t>
+              <a:t>[IMAGE SUGGESTION]: A visual diagram comparing Traditional Programming (Rules + Data -&gt; Answers) vs. Machine Learning (Answers + Data -&gt; Rules).</a:t>
             </a:r>
           </a:p>
         </p:txBody>
@@ -8648,12 +8662,11 @@
   <p:clrMapOvr>
     <a:masterClrMapping/>
   </p:clrMapOvr>
-  <p:transition spd="med"/>
 </p:sld>
 </file>
 
-<file path=ppt/slides/slide4.xml><?xml version="1.0" encoding="utf-8"?>
-<p:sld xmlns:a="http://schemas.openxmlformats.org/drawingml/2006/main" xmlns:r="http://schemas.openxmlformats.org/officeDocument/2006/relationships" xmlns:p="http://schemas.openxmlformats.org/presentationml/2006/main">
+<file path=ppt/slides/slide3.xml><?xml version="1.0" encoding="utf-8"?>
+<p:sld xmlns:a="http://schemas.openxmlformats.org/drawingml/2006/main" xmlns:p="http://schemas.openxmlformats.org/presentationml/2006/main" xmlns:r="http://schemas.openxmlformats.org/officeDocument/2006/relationships">
   <p:cSld>
     <p:spTree>
       <p:nvGrpSpPr>
@@ -8661,25 +8674,646 @@
         <p:cNvGrpSpPr/>
         <p:nvPr/>
       </p:nvGrpSpPr>
-      <p:grpSpPr>
-        <a:xfrm>
-          <a:off x="0" y="0"/>
-          <a:ext cx="0" cy="0"/>
-          <a:chOff x="0" y="0"/>
-          <a:chExt cx="0" cy="0"/>
-        </a:xfrm>
-      </p:grpSpPr>
+      <p:grpSpPr/>
+      <p:sp>
+        <p:nvSpPr>
+          <p:cNvPr id="2" name="Text Placeholder 1"/>
+          <p:cNvSpPr>
+            <a:spLocks noGrp="1"/>
+          </p:cNvSpPr>
+          <p:nvPr>
+            <p:ph type="body" idx="1" sz="quarter"/>
+          </p:nvPr>
+        </p:nvSpPr>
+        <p:spPr/>
+        <p:txBody>
+          <a:bodyPr/>
+          <a:lstStyle/>
+          <a:p>
+            <a:pPr/>
+            <a:r>
+              <a:t>What is Machine Learning?</a:t>
+            </a:r>
+          </a:p>
+          <a:p>
+            <a:pPr lvl="1"/>
+            <a:r>
+              <a:t>A subset of AI that enables systems to learn from data without explicit programming.</a:t>
+            </a:r>
+          </a:p>
+          <a:p>
+            <a:pPr/>
+            <a:r>
+              <a:t>Why Now?</a:t>
+            </a:r>
+          </a:p>
+          <a:p>
+            <a:pPr lvl="1"/>
+            <a:r>
+              <a:t>Explosion of Big Data availability.</a:t>
+            </a:r>
+          </a:p>
+          <a:p>
+            <a:pPr lvl="1"/>
+            <a:r>
+              <a:t>Advancements in computational power (GPUs/TPUs).</a:t>
+            </a:r>
+          </a:p>
+          <a:p>
+            <a:pPr lvl="1"/>
+            <a:r>
+              <a:t>Improvements in algorithms (Deep Learning).</a:t>
+            </a:r>
+          </a:p>
+        </p:txBody>
+      </p:sp>
+      <p:sp>
+        <p:nvSpPr>
+          <p:cNvPr id="3" name="Title 2"/>
+          <p:cNvSpPr>
+            <a:spLocks noGrp="1"/>
+          </p:cNvSpPr>
+          <p:nvPr>
+            <p:ph type="title"/>
+          </p:nvPr>
+        </p:nvSpPr>
+        <p:spPr/>
+        <p:txBody>
+          <a:bodyPr/>
+          <a:lstStyle/>
+          <a:p>
+            <a:r>
+              <a:t>Introduction to Machine Learning: What and Why</a:t>
+            </a:r>
+          </a:p>
+        </p:txBody>
+      </p:sp>
+      <p:sp>
+        <p:nvSpPr>
+          <p:cNvPr id="4" name="TextBox 3"/>
+          <p:cNvSpPr txBox="1"/>
+          <p:nvPr/>
+        </p:nvSpPr>
+        <p:spPr>
+          <a:xfrm>
+            <a:off x="914400" y="5029200"/>
+            <a:ext cx="7315200" cy="1371600"/>
+          </a:xfrm>
+          <a:prstGeom prst="rect">
+            <a:avLst/>
+          </a:prstGeom>
+          <a:noFill/>
+        </p:spPr>
+        <p:txBody>
+          <a:bodyPr wrap="square">
+            <a:spAutoFit/>
+          </a:bodyPr>
+          <a:lstStyle/>
+          <a:p/>
+          <a:p>
+            <a:pPr>
+              <a:defRPr sz="1200" i="1">
+                <a:solidFill>
+                  <a:srgbClr val="646464"/>
+                </a:solidFill>
+              </a:defRPr>
+            </a:pPr>
+            <a:r>
+              <a:t>[IMAGE SUGGESTION]: A visual diagram comparing Traditional Programming (Rules + Data -&gt; Answers) vs. Machine Learning (Answers + Data -&gt; Rules).</a:t>
+            </a:r>
+          </a:p>
+        </p:txBody>
+      </p:sp>
     </p:spTree>
-    <p:extLst>
-      <p:ext uri="{BB962C8B-B14F-4D97-AF65-F5344CB8AC3E}">
-        <p14:creationId xmlns:p14="http://schemas.microsoft.com/office/powerpoint/2010/main" val="1832912884"/>
-      </p:ext>
-    </p:extLst>
   </p:cSld>
   <p:clrMapOvr>
     <a:masterClrMapping/>
   </p:clrMapOvr>
-  <p:transition spd="med"/>
+</p:sld>
+</file>
+
+<file path=ppt/slides/slide4.xml><?xml version="1.0" encoding="utf-8"?>
+<p:sld xmlns:a="http://schemas.openxmlformats.org/drawingml/2006/main" xmlns:p="http://schemas.openxmlformats.org/presentationml/2006/main" xmlns:r="http://schemas.openxmlformats.org/officeDocument/2006/relationships">
+  <p:cSld>
+    <p:spTree>
+      <p:nvGrpSpPr>
+        <p:cNvPr id="1" name=""/>
+        <p:cNvGrpSpPr/>
+        <p:nvPr/>
+      </p:nvGrpSpPr>
+      <p:grpSpPr/>
+      <p:sp>
+        <p:nvSpPr>
+          <p:cNvPr id="2" name="Text Placeholder 1"/>
+          <p:cNvSpPr>
+            <a:spLocks noGrp="1"/>
+          </p:cNvSpPr>
+          <p:nvPr>
+            <p:ph type="body" idx="1" sz="quarter"/>
+          </p:nvPr>
+        </p:nvSpPr>
+        <p:spPr/>
+        <p:txBody>
+          <a:bodyPr/>
+          <a:lstStyle/>
+          <a:p>
+            <a:pPr/>
+            <a:r>
+              <a:t>Healthcare: Disease diagnosis, drug discovery, personalized medicine.</a:t>
+            </a:r>
+          </a:p>
+          <a:p>
+            <a:pPr/>
+            <a:r>
+              <a:t>Finance: Fraud detection, algorithmic trading, credit scoring.</a:t>
+            </a:r>
+          </a:p>
+          <a:p>
+            <a:pPr/>
+            <a:r>
+              <a:t>Retail: Product recommendations, inventory optimization.</a:t>
+            </a:r>
+          </a:p>
+          <a:p>
+            <a:pPr/>
+            <a:r>
+              <a:t>Transportation: Self-driving cars, route optimization.</a:t>
+            </a:r>
+          </a:p>
+          <a:p>
+            <a:pPr/>
+            <a:r>
+              <a:t>NLP: Language translation (Google Translate), Chatbots (ChatGPT).</a:t>
+            </a:r>
+          </a:p>
+        </p:txBody>
+      </p:sp>
+      <p:sp>
+        <p:nvSpPr>
+          <p:cNvPr id="3" name="Title 2"/>
+          <p:cNvSpPr>
+            <a:spLocks noGrp="1"/>
+          </p:cNvSpPr>
+          <p:nvPr>
+            <p:ph type="title"/>
+          </p:nvPr>
+        </p:nvSpPr>
+        <p:spPr/>
+        <p:txBody>
+          <a:bodyPr/>
+          <a:lstStyle/>
+          <a:p>
+            <a:r>
+              <a:t>Applications of Machine Learning</a:t>
+            </a:r>
+          </a:p>
+        </p:txBody>
+      </p:sp>
+      <p:sp>
+        <p:nvSpPr>
+          <p:cNvPr id="4" name="TextBox 3"/>
+          <p:cNvSpPr txBox="1"/>
+          <p:nvPr/>
+        </p:nvSpPr>
+        <p:spPr>
+          <a:xfrm>
+            <a:off x="914400" y="5029200"/>
+            <a:ext cx="7315200" cy="1371600"/>
+          </a:xfrm>
+          <a:prstGeom prst="rect">
+            <a:avLst/>
+          </a:prstGeom>
+          <a:noFill/>
+        </p:spPr>
+        <p:txBody>
+          <a:bodyPr wrap="square">
+            <a:spAutoFit/>
+          </a:bodyPr>
+          <a:lstStyle/>
+          <a:p/>
+          <a:p>
+            <a:pPr>
+              <a:defRPr sz="1200" i="1">
+                <a:solidFill>
+                  <a:srgbClr val="646464"/>
+                </a:solidFill>
+              </a:defRPr>
+            </a:pPr>
+            <a:r>
+              <a:t>[IMAGE SUGGESTION]: A visual collage showing icons representing Healthcare, Finance, Retail, and Transportation connected to a central brain or neural network icon.</a:t>
+            </a:r>
+          </a:p>
+        </p:txBody>
+      </p:sp>
+    </p:spTree>
+  </p:cSld>
+  <p:clrMapOvr>
+    <a:masterClrMapping/>
+  </p:clrMapOvr>
+</p:sld>
+</file>
+
+<file path=ppt/slides/slide4.xml><?xml version="1.0" encoding="utf-8"?>
+<p:sld xmlns:a="http://schemas.openxmlformats.org/drawingml/2006/main" xmlns:p="http://schemas.openxmlformats.org/presentationml/2006/main" xmlns:r="http://schemas.openxmlformats.org/officeDocument/2006/relationships">
+  <p:cSld>
+    <p:spTree>
+      <p:nvGrpSpPr>
+        <p:cNvPr id="1" name=""/>
+        <p:cNvGrpSpPr/>
+        <p:nvPr/>
+      </p:nvGrpSpPr>
+      <p:grpSpPr/>
+      <p:sp>
+        <p:nvSpPr>
+          <p:cNvPr id="2" name="Text Placeholder 1"/>
+          <p:cNvSpPr>
+            <a:spLocks noGrp="1"/>
+          </p:cNvSpPr>
+          <p:nvPr>
+            <p:ph type="body" idx="1" sz="quarter"/>
+          </p:nvPr>
+        </p:nvSpPr>
+        <p:spPr/>
+        <p:txBody>
+          <a:bodyPr/>
+          <a:lstStyle/>
+          <a:p>
+            <a:pPr/>
+            <a:r>
+              <a:t>Healthcare: Disease diagnosis, drug discovery, personalized medicine.</a:t>
+            </a:r>
+          </a:p>
+          <a:p>
+            <a:pPr/>
+            <a:r>
+              <a:t>Finance: Fraud detection, algorithmic trading, credit scoring.</a:t>
+            </a:r>
+          </a:p>
+          <a:p>
+            <a:pPr/>
+            <a:r>
+              <a:t>Retail: Product recommendations, inventory optimization.</a:t>
+            </a:r>
+          </a:p>
+          <a:p>
+            <a:pPr/>
+            <a:r>
+              <a:t>Transportation: Self-driving cars, route optimization.</a:t>
+            </a:r>
+          </a:p>
+          <a:p>
+            <a:pPr/>
+            <a:r>
+              <a:t>NLP: Language translation (Google Translate), Chatbots (ChatGPT).</a:t>
+            </a:r>
+          </a:p>
+        </p:txBody>
+      </p:sp>
+      <p:sp>
+        <p:nvSpPr>
+          <p:cNvPr id="3" name="Title 2"/>
+          <p:cNvSpPr>
+            <a:spLocks noGrp="1"/>
+          </p:cNvSpPr>
+          <p:nvPr>
+            <p:ph type="title"/>
+          </p:nvPr>
+        </p:nvSpPr>
+        <p:spPr/>
+        <p:txBody>
+          <a:bodyPr/>
+          <a:lstStyle/>
+          <a:p>
+            <a:r>
+              <a:t>Applications of Machine Learning</a:t>
+            </a:r>
+          </a:p>
+        </p:txBody>
+      </p:sp>
+      <p:sp>
+        <p:nvSpPr>
+          <p:cNvPr id="4" name="TextBox 3"/>
+          <p:cNvSpPr txBox="1"/>
+          <p:nvPr/>
+        </p:nvSpPr>
+        <p:spPr>
+          <a:xfrm>
+            <a:off x="914400" y="5029200"/>
+            <a:ext cx="7315200" cy="1371600"/>
+          </a:xfrm>
+          <a:prstGeom prst="rect">
+            <a:avLst/>
+          </a:prstGeom>
+          <a:noFill/>
+        </p:spPr>
+        <p:txBody>
+          <a:bodyPr wrap="square">
+            <a:spAutoFit/>
+          </a:bodyPr>
+          <a:lstStyle/>
+          <a:p/>
+          <a:p>
+            <a:pPr>
+              <a:defRPr sz="1200" i="1">
+                <a:solidFill>
+                  <a:srgbClr val="646464"/>
+                </a:solidFill>
+              </a:defRPr>
+            </a:pPr>
+            <a:r>
+              <a:t>[IMAGE SUGGESTION]: A visual collage showing icons representing Healthcare, Finance, Retail, and Transportation connected to a central brain or neural network icon.</a:t>
+            </a:r>
+          </a:p>
+        </p:txBody>
+      </p:sp>
+    </p:spTree>
+  </p:cSld>
+  <p:clrMapOvr>
+    <a:masterClrMapping/>
+  </p:clrMapOvr>
+</p:sld>
+</file>
+
+<file path=ppt/slides/slide5.xml><?xml version="1.0" encoding="utf-8"?>
+<p:sld xmlns:a="http://schemas.openxmlformats.org/drawingml/2006/main" xmlns:p="http://schemas.openxmlformats.org/presentationml/2006/main" xmlns:r="http://schemas.openxmlformats.org/officeDocument/2006/relationships">
+  <p:cSld>
+    <p:spTree>
+      <p:nvGrpSpPr>
+        <p:cNvPr id="1" name=""/>
+        <p:cNvGrpSpPr/>
+        <p:nvPr/>
+      </p:nvGrpSpPr>
+      <p:grpSpPr/>
+      <p:sp>
+        <p:nvSpPr>
+          <p:cNvPr id="2" name="Text Placeholder 1"/>
+          <p:cNvSpPr>
+            <a:spLocks noGrp="1"/>
+          </p:cNvSpPr>
+          <p:nvPr>
+            <p:ph type="body" idx="1" sz="quarter"/>
+          </p:nvPr>
+        </p:nvSpPr>
+        <p:spPr/>
+        <p:txBody>
+          <a:bodyPr/>
+          <a:lstStyle/>
+          <a:p>
+            <a:pPr/>
+            <a:r>
+              <a:t>Supervised Learning</a:t>
+            </a:r>
+          </a:p>
+          <a:p>
+            <a:pPr lvl="1"/>
+            <a:r>
+              <a:t>Learning with labeled data (Input -&gt; Output). E.g., Spam classification.</a:t>
+            </a:r>
+          </a:p>
+          <a:p>
+            <a:pPr/>
+            <a:r>
+              <a:t>Unsupervised Learning</a:t>
+            </a:r>
+          </a:p>
+          <a:p>
+            <a:pPr lvl="1"/>
+            <a:r>
+              <a:t>Finding hidden patterns in unlabeled data. E.g., Customer segmentation.</a:t>
+            </a:r>
+          </a:p>
+          <a:p>
+            <a:pPr/>
+            <a:r>
+              <a:t>Reinforcement Learning</a:t>
+            </a:r>
+          </a:p>
+          <a:p>
+            <a:pPr lvl="1"/>
+            <a:r>
+              <a:t>Learning through trial and error based on rewards. E.g., Game playing AI (AlphaGo).</a:t>
+            </a:r>
+          </a:p>
+        </p:txBody>
+      </p:sp>
+      <p:sp>
+        <p:nvSpPr>
+          <p:cNvPr id="3" name="Title 2"/>
+          <p:cNvSpPr>
+            <a:spLocks noGrp="1"/>
+          </p:cNvSpPr>
+          <p:nvPr>
+            <p:ph type="title"/>
+          </p:nvPr>
+        </p:nvSpPr>
+        <p:spPr/>
+        <p:txBody>
+          <a:bodyPr/>
+          <a:lstStyle/>
+          <a:p>
+            <a:r>
+              <a:t>Types of Machine Learning</a:t>
+            </a:r>
+          </a:p>
+        </p:txBody>
+      </p:sp>
+      <p:sp>
+        <p:nvSpPr>
+          <p:cNvPr id="4" name="TextBox 3"/>
+          <p:cNvSpPr txBox="1"/>
+          <p:nvPr/>
+        </p:nvSpPr>
+        <p:spPr>
+          <a:xfrm>
+            <a:off x="914400" y="5029200"/>
+            <a:ext cx="7315200" cy="1371600"/>
+          </a:xfrm>
+          <a:prstGeom prst="rect">
+            <a:avLst/>
+          </a:prstGeom>
+          <a:noFill/>
+        </p:spPr>
+        <p:txBody>
+          <a:bodyPr wrap="square">
+            <a:spAutoFit/>
+          </a:bodyPr>
+          <a:lstStyle/>
+          <a:p/>
+          <a:p>
+            <a:pPr>
+              <a:defRPr sz="1200" i="1">
+                <a:solidFill>
+                  <a:srgbClr val="646464"/>
+                </a:solidFill>
+              </a:defRPr>
+            </a:pPr>
+            <a:r>
+              <a:t>[IMAGE SUGGESTION]: Three distinct panels: 1. A teacher guiding a student (Supervised), 2. A person sorting mixed objects into groups (Unsupervised), 3. A robot navigating a maze for a treat (Reinforcement).</a:t>
+            </a:r>
+          </a:p>
+        </p:txBody>
+      </p:sp>
+    </p:spTree>
+  </p:cSld>
+  <p:clrMapOvr>
+    <a:masterClrMapping/>
+  </p:clrMapOvr>
+</p:sld>
+</file>
+
+<file path=ppt/slides/slide6.xml><?xml version="1.0" encoding="utf-8"?>
+<p:sld xmlns:a="http://schemas.openxmlformats.org/drawingml/2006/main" xmlns:p="http://schemas.openxmlformats.org/presentationml/2006/main" xmlns:r="http://schemas.openxmlformats.org/officeDocument/2006/relationships">
+  <p:cSld>
+    <p:spTree>
+      <p:nvGrpSpPr>
+        <p:cNvPr id="1" name=""/>
+        <p:cNvGrpSpPr/>
+        <p:nvPr/>
+      </p:nvGrpSpPr>
+      <p:grpSpPr/>
+      <p:sp>
+        <p:nvSpPr>
+          <p:cNvPr id="2" name="Text Placeholder 1"/>
+          <p:cNvSpPr>
+            <a:spLocks noGrp="1"/>
+          </p:cNvSpPr>
+          <p:nvPr>
+            <p:ph type="body" idx="1" sz="quarter"/>
+          </p:nvPr>
+        </p:nvSpPr>
+        <p:spPr/>
+        <p:txBody>
+          <a:bodyPr/>
+          <a:lstStyle/>
+          <a:p>
+            <a:pPr/>
+            <a:r>
+              <a:t>Data Quality: 'Garbage In, Garbage Out' - Models depend on good data.</a:t>
+            </a:r>
+          </a:p>
+          <a:p>
+            <a:pPr/>
+            <a:r>
+              <a:t>Overfitting/Underfitting: The model memorizes noise or fails to learn patterns.</a:t>
+            </a:r>
+          </a:p>
+          <a:p>
+            <a:pPr/>
+            <a:r>
+              <a:t>Bias and Fairness: AI can inherit biases from training data.</a:t>
+            </a:r>
+          </a:p>
+          <a:p>
+            <a:pPr/>
+            <a:r>
+              <a:t>Explainability (Black Box): Deep learning models are hard to interpret.</a:t>
+            </a:r>
+          </a:p>
+          <a:p>
+            <a:pPr/>
+            <a:r>
+              <a:t>Computational Cost: Training large models is expensive and energy-intensive.</a:t>
+            </a:r>
+          </a:p>
+        </p:txBody>
+      </p:sp>
+      <p:sp>
+        <p:nvSpPr>
+          <p:cNvPr id="3" name="Title 2"/>
+          <p:cNvSpPr>
+            <a:spLocks noGrp="1"/>
+          </p:cNvSpPr>
+          <p:nvPr>
+            <p:ph type="title"/>
+          </p:nvPr>
+        </p:nvSpPr>
+        <p:spPr/>
+        <p:txBody>
+          <a:bodyPr/>
+          <a:lstStyle/>
+          <a:p>
+            <a:r>
+              <a:t>Challenges in Machine Learning</a:t>
+            </a:r>
+          </a:p>
+        </p:txBody>
+      </p:sp>
+      <p:sp>
+        <p:nvSpPr>
+          <p:cNvPr id="4" name="TextBox 3"/>
+          <p:cNvSpPr txBox="1"/>
+          <p:nvPr/>
+        </p:nvSpPr>
+        <p:spPr>
+          <a:xfrm>
+            <a:off x="914400" y="5029200"/>
+            <a:ext cx="7315200" cy="1371600"/>
+          </a:xfrm>
+          <a:prstGeom prst="rect">
+            <a:avLst/>
+          </a:prstGeom>
+          <a:noFill/>
+        </p:spPr>
+        <p:txBody>
+          <a:bodyPr wrap="square">
+            <a:spAutoFit/>
+          </a:bodyPr>
+          <a:lstStyle/>
+          <a:p/>
+          <a:p>
+            <a:pPr>
+              <a:defRPr sz="1200" i="1">
+                <a:solidFill>
+                  <a:srgbClr val="646464"/>
+                </a:solidFill>
+              </a:defRPr>
+            </a:pPr>
+            <a:r>
+              <a:t>[IMAGE SUGGESTION]: An infographic showing a hurdle race where the hurdles are labeled 'Bad Data', 'Bias', 'Complexity', and 'Cost'.</a:t>
+            </a:r>
+          </a:p>
+        </p:txBody>
+      </p:sp>
+    </p:spTree>
+  </p:cSld>
+  <p:clrMapOvr>
+    <a:masterClrMapping/>
+  </p:clrMapOvr>
+</p:sld>
+</file>
+
+<file path=ppt/slides/slide7.xml><?xml version="1.0" encoding="utf-8"?>
+<p:sld xmlns:a="http://schemas.openxmlformats.org/drawingml/2006/main" xmlns:p="http://schemas.openxmlformats.org/presentationml/2006/main" xmlns:r="http://schemas.openxmlformats.org/officeDocument/2006/relationships">
+  <p:cSld>
+    <p:spTree>
+      <p:nvGrpSpPr>
+        <p:cNvPr id="1" name=""/>
+        <p:cNvGrpSpPr/>
+        <p:nvPr/>
+      </p:nvGrpSpPr>
+      <p:grpSpPr/>
+      <p:sp>
+        <p:nvSpPr>
+          <p:cNvPr id="2" name="Text Placeholder 1"/>
+          <p:cNvSpPr>
+            <a:spLocks noGrp="1"/>
+          </p:cNvSpPr>
+          <p:nvPr>
+            <p:ph type="body" idx="1" sz="quarter"/>
+          </p:nvPr>
+        </p:nvSpPr>
+        <p:spPr/>
+        <p:txBody>
+          <a:bodyPr/>
+          <a:lstStyle/>
+          <a:p/>
+        </p:txBody>
+      </p:sp>
+    </p:spTree>
+  </p:cSld>
+  <p:clrMapOvr>
+    <a:masterClrMapping/>
+  </p:clrMapOvr>
 </p:sld>
 </file>
 

</xml_diff>